<commit_message>
add photos for the talk
</commit_message>
<xml_diff>
--- a/assets/images/Practical-steps/Practical-steps-to-more-inclusive-practice.pptx
+++ b/assets/images/Practical-steps/Practical-steps-to-more-inclusive-practice.pptx
@@ -390,12 +390,20 @@
 </p:presentation>
 </file>
 
+<file path=ppt/revisionInfo.xml><?xml version="1.0" encoding="utf-8"?>
+<p1510:revInfo xmlns:a="http://schemas.openxmlformats.org/drawingml/2006/main" xmlns:r="http://schemas.openxmlformats.org/officeDocument/2006/relationships" xmlns:p1510="http://schemas.microsoft.com/office/powerpoint/2015/10/main">
+  <p1510:revLst>
+    <p1510:client id="{950B9AD0-AA6B-6D46-B65F-68E8C7AE21F4}" v="2" dt="2026-05-07T10:13:55.965"/>
+  </p1510:revLst>
+</p1510:revInfo>
+</file>
+
 <file path=ppt/changesInfos/changesInfo1.xml><?xml version="1.0" encoding="utf-8"?>
 <pc:chgInfo xmlns:a="http://schemas.openxmlformats.org/drawingml/2006/main" xmlns:r="http://schemas.openxmlformats.org/officeDocument/2006/relationships" xmlns:ac="http://schemas.microsoft.com/office/drawing/2013/main/command" xmlns:pc="http://schemas.microsoft.com/office/powerpoint/2013/main/command">
   <pc:docChgLst>
     <pc:chgData name="Stephanie Krus" userId="125da740-f10c-4e8d-9e12-749d9feb0ca0" providerId="ADAL" clId="{DA2AC1A5-5707-5EAB-903D-CC21B3DA70F0}"/>
     <pc:docChg chg="modSld">
-      <pc:chgData name="Stephanie Krus" userId="125da740-f10c-4e8d-9e12-749d9feb0ca0" providerId="ADAL" clId="{DA2AC1A5-5707-5EAB-903D-CC21B3DA70F0}" dt="2026-05-05T18:13:50.562" v="19" actId="20577"/>
+      <pc:chgData name="Stephanie Krus" userId="125da740-f10c-4e8d-9e12-749d9feb0ca0" providerId="ADAL" clId="{DA2AC1A5-5707-5EAB-903D-CC21B3DA70F0}" dt="2026-05-07T10:13:53.903" v="22" actId="20577"/>
       <pc:docMkLst>
         <pc:docMk/>
       </pc:docMkLst>
@@ -411,6 +419,28 @@
             <pc:docMk/>
             <pc:sldMk cId="0" sldId="256"/>
             <ac:spMk id="116" creationId="{00000000-0000-0000-0000-000000000000}"/>
+          </ac:spMkLst>
+        </pc:spChg>
+      </pc:sldChg>
+      <pc:sldChg chg="modNotesTx">
+        <pc:chgData name="Stephanie Krus" userId="125da740-f10c-4e8d-9e12-749d9feb0ca0" providerId="ADAL" clId="{DA2AC1A5-5707-5EAB-903D-CC21B3DA70F0}" dt="2026-05-07T10:13:31.583" v="20" actId="20577"/>
+        <pc:sldMkLst>
+          <pc:docMk/>
+          <pc:sldMk cId="0" sldId="267"/>
+        </pc:sldMkLst>
+      </pc:sldChg>
+      <pc:sldChg chg="modSp mod">
+        <pc:chgData name="Stephanie Krus" userId="125da740-f10c-4e8d-9e12-749d9feb0ca0" providerId="ADAL" clId="{DA2AC1A5-5707-5EAB-903D-CC21B3DA70F0}" dt="2026-05-07T10:13:53.903" v="22" actId="20577"/>
+        <pc:sldMkLst>
+          <pc:docMk/>
+          <pc:sldMk cId="0" sldId="292"/>
+        </pc:sldMkLst>
+        <pc:spChg chg="mod">
+          <ac:chgData name="Stephanie Krus" userId="125da740-f10c-4e8d-9e12-749d9feb0ca0" providerId="ADAL" clId="{DA2AC1A5-5707-5EAB-903D-CC21B3DA70F0}" dt="2026-05-07T10:13:53.903" v="22" actId="20577"/>
+          <ac:spMkLst>
+            <pc:docMk/>
+            <pc:sldMk cId="0" sldId="292"/>
+            <ac:spMk id="363" creationId="{00000000-0000-0000-0000-000000000000}"/>
           </ac:spMkLst>
         </pc:spChg>
       </pc:sldChg>
@@ -1607,14 +1637,14 @@
               <a:buNone/>
             </a:pPr>
             <a:r>
-              <a:rPr lang="en-GB">
+              <a:rPr lang="en-GB" dirty="0">
                 <a:solidFill>
                   <a:schemeClr val="dk1"/>
                 </a:solidFill>
               </a:rPr>
               <a:t>Most of these errors are not that hard to fix</a:t>
             </a:r>
-            <a:endParaRPr>
+            <a:endParaRPr dirty="0">
               <a:solidFill>
                 <a:schemeClr val="dk1"/>
               </a:solidFill>
@@ -1635,7 +1665,7 @@
               <a:buFont typeface="Arial"/>
               <a:buNone/>
             </a:pPr>
-            <a:endParaRPr>
+            <a:endParaRPr dirty="0">
               <a:solidFill>
                 <a:schemeClr val="dk1"/>
               </a:solidFill>
@@ -1657,14 +1687,14 @@
               <a:buNone/>
             </a:pPr>
             <a:r>
-              <a:rPr lang="en-GB">
+              <a:rPr lang="en-GB" dirty="0">
                 <a:solidFill>
                   <a:schemeClr val="dk1"/>
                 </a:solidFill>
               </a:rPr>
               <a:t>84%  of the pages had low contrast text errors, this is when the colour of the text is not contrasted enough with the background. There are many tools to help you with this</a:t>
             </a:r>
-            <a:endParaRPr>
+            <a:endParaRPr dirty="0">
               <a:solidFill>
                 <a:schemeClr val="dk1"/>
               </a:solidFill>
@@ -1685,7 +1715,7 @@
               <a:buFont typeface="Arial"/>
               <a:buNone/>
             </a:pPr>
-            <a:endParaRPr>
+            <a:endParaRPr dirty="0">
               <a:solidFill>
                 <a:schemeClr val="dk1"/>
               </a:solidFill>
@@ -1707,14 +1737,26 @@
               <a:buNone/>
             </a:pPr>
             <a:r>
-              <a:rPr lang="en-GB">
-                <a:solidFill>
-                  <a:schemeClr val="dk1"/>
-                </a:solidFill>
-              </a:rPr>
-              <a:t>53%  have missing alternative text for images or diagrams, again there is a lot of guidance to help you learn how to write good alternative texts </a:t>
-            </a:r>
-            <a:endParaRPr>
+              <a:rPr lang="en-GB" dirty="0"/>
+              <a:t>53%  have missing alternative text for images or diagrams, this is the text description which will appear if your image doesn’t load or which will be read by a screen reader for people who cannot see your image, again there is a lot of guidance to help you learn how to write good alternative texts</a:t>
+            </a:r>
+          </a:p>
+          <a:p>
+            <a:pPr marL="0" lvl="0" indent="0" algn="l" rtl="0">
+              <a:spcBef>
+                <a:spcPts val="0"/>
+              </a:spcBef>
+              <a:spcAft>
+                <a:spcPts val="0"/>
+              </a:spcAft>
+              <a:buClr>
+                <a:schemeClr val="dk1"/>
+              </a:buClr>
+              <a:buSzPts val="1100"/>
+              <a:buFont typeface="Arial"/>
+              <a:buNone/>
+            </a:pPr>
+            <a:endParaRPr dirty="0">
               <a:solidFill>
                 <a:schemeClr val="dk1"/>
               </a:solidFill>
@@ -1735,36 +1777,15 @@
               <a:buFont typeface="Arial"/>
               <a:buNone/>
             </a:pPr>
-            <a:endParaRPr>
-              <a:solidFill>
-                <a:schemeClr val="dk1"/>
-              </a:solidFill>
-            </a:endParaRPr>
-          </a:p>
-          <a:p>
-            <a:pPr marL="0" lvl="0" indent="0" algn="l" rtl="0">
-              <a:spcBef>
-                <a:spcPts val="0"/>
-              </a:spcBef>
-              <a:spcAft>
-                <a:spcPts val="0"/>
-              </a:spcAft>
-              <a:buClr>
-                <a:schemeClr val="dk1"/>
-              </a:buClr>
-              <a:buSzPts val="1100"/>
-              <a:buFont typeface="Arial"/>
-              <a:buNone/>
-            </a:pPr>
-            <a:r>
-              <a:rPr lang="en-GB">
+            <a:r>
+              <a:rPr lang="en-GB" dirty="0">
                 <a:solidFill>
                   <a:schemeClr val="dk1"/>
                 </a:solidFill>
               </a:rPr>
               <a:t>46% of the pages have empty links, this is when you use an icon for a link for example, like the social media icon in the footer of your website</a:t>
             </a:r>
-            <a:endParaRPr sz="1200">
+            <a:endParaRPr sz="1200" dirty="0">
               <a:solidFill>
                 <a:schemeClr val="dk1"/>
               </a:solidFill>
@@ -1789,7 +1810,7 @@
               <a:buFont typeface="Arial"/>
               <a:buNone/>
             </a:pPr>
-            <a:endParaRPr>
+            <a:endParaRPr dirty="0">
               <a:solidFill>
                 <a:schemeClr val="dk1"/>
               </a:solidFill>
@@ -1810,7 +1831,7 @@
               <a:buFont typeface="Arial"/>
               <a:buNone/>
             </a:pPr>
-            <a:endParaRPr/>
+            <a:endParaRPr dirty="0"/>
           </a:p>
           <a:p>
             <a:pPr marL="0" lvl="0" indent="0" algn="l" rtl="0">
@@ -1827,7 +1848,7 @@
               <a:buFont typeface="Arial"/>
               <a:buNone/>
             </a:pPr>
-            <a:endParaRPr/>
+            <a:endParaRPr dirty="0"/>
           </a:p>
           <a:p>
             <a:pPr marL="0" lvl="0" indent="0" algn="l" rtl="0">
@@ -1844,7 +1865,7 @@
               <a:buFont typeface="Arial"/>
               <a:buNone/>
             </a:pPr>
-            <a:endParaRPr/>
+            <a:endParaRPr dirty="0"/>
           </a:p>
         </p:txBody>
       </p:sp>
@@ -8371,7 +8392,7 @@
         </p:nvSpPr>
         <p:spPr>
           <a:xfrm>
-            <a:off x="381300" y="685800"/>
+            <a:off x="381000" y="685800"/>
             <a:ext cx="6096000" cy="3429000"/>
           </a:xfrm>
           <a:custGeom>
@@ -8439,6 +8460,30 @@
               <a:buFont typeface="Arial"/>
               <a:buNone/>
             </a:pPr>
+            <a:r>
+              <a:rPr lang="en-GB" dirty="0"/>
+              <a:t>Do go back to the slides for the instructions and try this for yourself.</a:t>
+            </a:r>
+            <a:br>
+              <a:rPr lang="en-GB" dirty="0"/>
+            </a:br>
+            <a:br>
+              <a:rPr lang="en-GB" dirty="0"/>
+            </a:br>
+            <a:r>
+              <a:rPr lang="en-GB"/>
+              <a:t>I’ve made some video demos, which you can access with the links for the slides</a:t>
+            </a:r>
+            <a:br>
+              <a:rPr lang="en-GB"/>
+            </a:br>
+            <a:br>
+              <a:rPr lang="en-GB"/>
+            </a:br>
+            <a:r>
+              <a:rPr lang="en-GB"/>
+              <a:t>The rest are resources to understand digital inclusion a bit more.</a:t>
+            </a:r>
             <a:endParaRPr>
               <a:solidFill>
                 <a:schemeClr val="dk1"/>
@@ -37272,7 +37317,7 @@
               <a:buChar char="●"/>
             </a:pPr>
             <a:r>
-              <a:rPr lang="en-GB" sz="2000" u="sng">
+              <a:rPr lang="en-GB" sz="2000" u="sng" dirty="0">
                 <a:solidFill>
                   <a:srgbClr val="FFFFFF"/>
                 </a:solidFill>
@@ -37291,7 +37336,7 @@
               <a:t>Digital Inclusion Action Plan - GOV.UK</a:t>
             </a:r>
             <a:r>
-              <a:rPr lang="en-GB" sz="2000">
+              <a:rPr lang="en-GB" sz="2000" dirty="0">
                 <a:solidFill>
                   <a:srgbClr val="FFFFFF"/>
                 </a:solidFill>
@@ -37302,7 +37347,7 @@
               </a:rPr>
               <a:t>  Feb 2025</a:t>
             </a:r>
-            <a:endParaRPr sz="2000">
+            <a:endParaRPr sz="2000" dirty="0">
               <a:solidFill>
                 <a:srgbClr val="FFFFFF"/>
               </a:solidFill>
@@ -37331,7 +37376,7 @@
               <a:buChar char="●"/>
             </a:pPr>
             <a:r>
-              <a:rPr lang="en-GB" sz="2000" u="sng">
+              <a:rPr lang="en-GB" sz="2000" u="sng" dirty="0">
                 <a:solidFill>
                   <a:srgbClr val="FFFFFF"/>
                 </a:solidFill>
@@ -37349,7 +37394,7 @@
               </a:rPr>
               <a:t>Lloyds’ UK Consumer Digital Index 2025</a:t>
             </a:r>
-            <a:endParaRPr sz="2000">
+            <a:endParaRPr sz="2000" dirty="0">
               <a:solidFill>
                 <a:srgbClr val="FFFFFF"/>
               </a:solidFill>
@@ -37378,7 +37423,7 @@
               <a:buChar char="●"/>
             </a:pPr>
             <a:r>
-              <a:rPr lang="en-GB" sz="2000" u="sng">
+              <a:rPr lang="en-GB" sz="2000" u="sng" dirty="0">
                 <a:solidFill>
                   <a:srgbClr val="FFFFFF"/>
                 </a:solidFill>
@@ -37396,7 +37441,7 @@
               </a:rPr>
               <a:t>Good Things Foundation - Our digital nation</a:t>
             </a:r>
-            <a:endParaRPr sz="2000">
+            <a:endParaRPr sz="2000" dirty="0">
               <a:solidFill>
                 <a:srgbClr val="FFFFFF"/>
               </a:solidFill>
@@ -37425,7 +37470,7 @@
               <a:buChar char="●"/>
             </a:pPr>
             <a:r>
-              <a:rPr lang="en-GB" sz="2000" u="sng">
+              <a:rPr lang="en-GB" sz="2000" u="sng" dirty="0">
                 <a:solidFill>
                   <a:srgbClr val="FFFFFF"/>
                 </a:solidFill>
@@ -37444,7 +37489,7 @@
               <a:t>Essential digital skills framework</a:t>
             </a:r>
             <a:r>
-              <a:rPr lang="en-GB" sz="2000">
+              <a:rPr lang="en-GB" sz="2000" dirty="0">
                 <a:solidFill>
                   <a:srgbClr val="FFFFFF"/>
                 </a:solidFill>
@@ -37455,89 +37500,7 @@
               </a:rPr>
               <a:t> - GOV.UK - useful to assess your participants skills</a:t>
             </a:r>
-            <a:endParaRPr sz="2000">
-              <a:solidFill>
-                <a:srgbClr val="FFFFFF"/>
-              </a:solidFill>
-              <a:latin typeface="Roboto"/>
-              <a:ea typeface="Roboto"/>
-              <a:cs typeface="Roboto"/>
-              <a:sym typeface="Roboto"/>
-            </a:endParaRPr>
-          </a:p>
-          <a:p>
-            <a:pPr marL="457200" lvl="0" indent="-355600" algn="l" rtl="0">
-              <a:lnSpc>
-                <a:spcPct val="150000"/>
-              </a:lnSpc>
-              <a:spcBef>
-                <a:spcPts val="1000"/>
-              </a:spcBef>
-              <a:spcAft>
-                <a:spcPts val="0"/>
-              </a:spcAft>
-              <a:buClr>
-                <a:srgbClr val="FFFFFF"/>
-              </a:buClr>
-              <a:buSzPts val="2000"/>
-              <a:buFont typeface="Roboto"/>
-              <a:buChar char="●"/>
-            </a:pPr>
-            <a:r>
-              <a:rPr lang="en-GB" sz="2000" u="sng">
-                <a:solidFill>
-                  <a:srgbClr val="FFFFFF"/>
-                </a:solidFill>
-                <a:latin typeface="Roboto"/>
-                <a:ea typeface="Roboto"/>
-                <a:cs typeface="Roboto"/>
-                <a:sym typeface="Roboto"/>
-                <a:hlinkClick r:id="rId7">
-                  <a:extLst>
-                    <a:ext uri="{A12FA001-AC4F-418D-AE19-62706E023703}">
-                      <ahyp:hlinkClr xmlns:ahyp="http://schemas.microsoft.com/office/drawing/2018/hyperlinkcolor" val="tx"/>
-                    </a:ext>
-                  </a:extLst>
-                </a:hlinkClick>
-              </a:rPr>
-              <a:t>Use Chrome Dev Tools to simulate throttling</a:t>
-            </a:r>
-            <a:r>
-              <a:rPr lang="en-GB" sz="2000">
-                <a:solidFill>
-                  <a:srgbClr val="FFFFFF"/>
-                </a:solidFill>
-                <a:latin typeface="Roboto"/>
-                <a:ea typeface="Roboto"/>
-                <a:cs typeface="Roboto"/>
-                <a:sym typeface="Roboto"/>
-              </a:rPr>
-              <a:t> - YouTube</a:t>
-            </a:r>
-            <a:endParaRPr sz="2000">
-              <a:solidFill>
-                <a:srgbClr val="FFFFFF"/>
-              </a:solidFill>
-              <a:latin typeface="Roboto"/>
-              <a:ea typeface="Roboto"/>
-              <a:cs typeface="Roboto"/>
-              <a:sym typeface="Roboto"/>
-            </a:endParaRPr>
-          </a:p>
-          <a:p>
-            <a:pPr marL="0" lvl="0" indent="0" algn="l" rtl="0">
-              <a:lnSpc>
-                <a:spcPct val="150000"/>
-              </a:lnSpc>
-              <a:spcBef>
-                <a:spcPts val="1000"/>
-              </a:spcBef>
-              <a:spcAft>
-                <a:spcPts val="1200"/>
-              </a:spcAft>
-              <a:buNone/>
-            </a:pPr>
-            <a:endParaRPr sz="2000">
+            <a:endParaRPr sz="2000" dirty="0">
               <a:solidFill>
                 <a:srgbClr val="FFFFFF"/>
               </a:solidFill>

</xml_diff>

<commit_message>
last updates to the talk
</commit_message>
<xml_diff>
--- a/assets/images/Practical-steps/Practical-steps-to-more-inclusive-practice.pptx
+++ b/assets/images/Practical-steps/Practical-steps-to-more-inclusive-practice.pptx
@@ -393,75 +393,9 @@
 <file path=ppt/revisionInfo.xml><?xml version="1.0" encoding="utf-8"?>
 <p1510:revInfo xmlns:a="http://schemas.openxmlformats.org/drawingml/2006/main" xmlns:r="http://schemas.openxmlformats.org/officeDocument/2006/relationships" xmlns:p1510="http://schemas.microsoft.com/office/powerpoint/2015/10/main">
   <p1510:revLst>
-    <p1510:client id="{950B9AD0-AA6B-6D46-B65F-68E8C7AE21F4}" v="2" dt="2026-05-07T10:13:55.965"/>
+    <p1510:client id="{FF9C7986-8AEB-314E-8430-65DC647FE2CE}" v="6" dt="2026-06-07T07:20:40.643"/>
   </p1510:revLst>
 </p1510:revInfo>
-</file>
-
-<file path=ppt/changesInfos/changesInfo1.xml><?xml version="1.0" encoding="utf-8"?>
-<pc:chgInfo xmlns:a="http://schemas.openxmlformats.org/drawingml/2006/main" xmlns:r="http://schemas.openxmlformats.org/officeDocument/2006/relationships" xmlns:ac="http://schemas.microsoft.com/office/drawing/2013/main/command" xmlns:pc="http://schemas.microsoft.com/office/powerpoint/2013/main/command">
-  <pc:docChgLst>
-    <pc:chgData name="Stephanie Krus" userId="125da740-f10c-4e8d-9e12-749d9feb0ca0" providerId="ADAL" clId="{DA2AC1A5-5707-5EAB-903D-CC21B3DA70F0}"/>
-    <pc:docChg chg="modSld">
-      <pc:chgData name="Stephanie Krus" userId="125da740-f10c-4e8d-9e12-749d9feb0ca0" providerId="ADAL" clId="{DA2AC1A5-5707-5EAB-903D-CC21B3DA70F0}" dt="2026-05-07T10:13:53.903" v="22" actId="20577"/>
-      <pc:docMkLst>
-        <pc:docMk/>
-      </pc:docMkLst>
-      <pc:sldChg chg="modSp mod">
-        <pc:chgData name="Stephanie Krus" userId="125da740-f10c-4e8d-9e12-749d9feb0ca0" providerId="ADAL" clId="{DA2AC1A5-5707-5EAB-903D-CC21B3DA70F0}" dt="2026-04-27T14:10:22.857" v="1" actId="20577"/>
-        <pc:sldMkLst>
-          <pc:docMk/>
-          <pc:sldMk cId="0" sldId="256"/>
-        </pc:sldMkLst>
-        <pc:spChg chg="mod">
-          <ac:chgData name="Stephanie Krus" userId="125da740-f10c-4e8d-9e12-749d9feb0ca0" providerId="ADAL" clId="{DA2AC1A5-5707-5EAB-903D-CC21B3DA70F0}" dt="2026-04-27T14:10:22.857" v="1" actId="20577"/>
-          <ac:spMkLst>
-            <pc:docMk/>
-            <pc:sldMk cId="0" sldId="256"/>
-            <ac:spMk id="116" creationId="{00000000-0000-0000-0000-000000000000}"/>
-          </ac:spMkLst>
-        </pc:spChg>
-      </pc:sldChg>
-      <pc:sldChg chg="modNotesTx">
-        <pc:chgData name="Stephanie Krus" userId="125da740-f10c-4e8d-9e12-749d9feb0ca0" providerId="ADAL" clId="{DA2AC1A5-5707-5EAB-903D-CC21B3DA70F0}" dt="2026-05-07T10:13:31.583" v="20" actId="20577"/>
-        <pc:sldMkLst>
-          <pc:docMk/>
-          <pc:sldMk cId="0" sldId="267"/>
-        </pc:sldMkLst>
-      </pc:sldChg>
-      <pc:sldChg chg="modSp mod">
-        <pc:chgData name="Stephanie Krus" userId="125da740-f10c-4e8d-9e12-749d9feb0ca0" providerId="ADAL" clId="{DA2AC1A5-5707-5EAB-903D-CC21B3DA70F0}" dt="2026-05-07T10:13:53.903" v="22" actId="20577"/>
-        <pc:sldMkLst>
-          <pc:docMk/>
-          <pc:sldMk cId="0" sldId="292"/>
-        </pc:sldMkLst>
-        <pc:spChg chg="mod">
-          <ac:chgData name="Stephanie Krus" userId="125da740-f10c-4e8d-9e12-749d9feb0ca0" providerId="ADAL" clId="{DA2AC1A5-5707-5EAB-903D-CC21B3DA70F0}" dt="2026-05-07T10:13:53.903" v="22" actId="20577"/>
-          <ac:spMkLst>
-            <pc:docMk/>
-            <pc:sldMk cId="0" sldId="292"/>
-            <ac:spMk id="363" creationId="{00000000-0000-0000-0000-000000000000}"/>
-          </ac:spMkLst>
-        </pc:spChg>
-      </pc:sldChg>
-      <pc:sldChg chg="modSp mod">
-        <pc:chgData name="Stephanie Krus" userId="125da740-f10c-4e8d-9e12-749d9feb0ca0" providerId="ADAL" clId="{DA2AC1A5-5707-5EAB-903D-CC21B3DA70F0}" dt="2026-05-05T18:13:50.562" v="19" actId="20577"/>
-        <pc:sldMkLst>
-          <pc:docMk/>
-          <pc:sldMk cId="0" sldId="321"/>
-        </pc:sldMkLst>
-        <pc:spChg chg="mod">
-          <ac:chgData name="Stephanie Krus" userId="125da740-f10c-4e8d-9e12-749d9feb0ca0" providerId="ADAL" clId="{DA2AC1A5-5707-5EAB-903D-CC21B3DA70F0}" dt="2026-05-05T18:13:50.562" v="19" actId="20577"/>
-          <ac:spMkLst>
-            <pc:docMk/>
-            <pc:sldMk cId="0" sldId="321"/>
-            <ac:spMk id="545" creationId="{00000000-0000-0000-0000-000000000000}"/>
-          </ac:spMkLst>
-        </pc:spChg>
-      </pc:sldChg>
-    </pc:docChg>
-  </pc:docChgLst>
-</pc:chgInfo>
 </file>
 
 <file path=ppt/notesMasters/notesMaster1.xml><?xml version="1.0" encoding="utf-8"?>
@@ -8471,20 +8405,20 @@
               <a:rPr lang="en-GB" dirty="0"/>
             </a:br>
             <a:r>
-              <a:rPr lang="en-GB"/>
+              <a:rPr lang="en-GB" dirty="0"/>
               <a:t>I’ve made some video demos, which you can access with the links for the slides</a:t>
             </a:r>
             <a:br>
-              <a:rPr lang="en-GB"/>
+              <a:rPr lang="en-GB" dirty="0"/>
             </a:br>
             <a:br>
-              <a:rPr lang="en-GB"/>
+              <a:rPr lang="en-GB" dirty="0"/>
             </a:br>
             <a:r>
-              <a:rPr lang="en-GB"/>
+              <a:rPr lang="en-GB" dirty="0"/>
               <a:t>The rest are resources to understand digital inclusion a bit more.</a:t>
             </a:r>
-            <a:endParaRPr>
+            <a:endParaRPr dirty="0">
               <a:solidFill>
                 <a:schemeClr val="dk1"/>
               </a:solidFill>
@@ -12426,14 +12360,14 @@
               <a:buNone/>
             </a:pPr>
             <a:r>
-              <a:rPr lang="en-GB">
+              <a:rPr lang="en-GB" dirty="0">
                 <a:solidFill>
                   <a:schemeClr val="dk1"/>
                 </a:solidFill>
               </a:rPr>
               <a:t>and to finish this section about inclusion, I’ve put more general resources here. The last link is about liberating structures, which is a great way to change the way you facilitate activities, and allow for more voices to be heard. It’s really good and if you do not know about it, you should have a look.</a:t>
             </a:r>
-            <a:endParaRPr>
+            <a:endParaRPr dirty="0">
               <a:solidFill>
                 <a:schemeClr val="dk1"/>
               </a:solidFill>
@@ -13392,7 +13326,7 @@
                   <a:schemeClr val="dk1"/>
                 </a:solidFill>
               </a:rPr>
-              <a:t>participant had low digital skills, in fact, most of the Syrian refugees never had an email address before coming to the UK</a:t>
+              <a:t>participants had low digital skills, in fact, most of the Syrian refugees never had an email address before coming to the UK</a:t>
             </a:r>
             <a:endParaRPr dirty="0">
               <a:solidFill>
@@ -13622,7 +13556,11 @@
                 <a:cs typeface="Roboto"/>
                 <a:sym typeface="Roboto"/>
               </a:rPr>
-              <a:t>Knowing that I would be speaking to people in vulnerable situations like refugees and people at risk of homelessness, I should have been better prepared, I wasn’t and was lucky it worked ok for everyone. Now that I’m more experienced and I would do it differently.</a:t>
+              <a:t>Knowing that I would be speaking to people in vulnerable situations like refugees and people at risk of homelessness, I should have been better prepared, I wasn’t and was lucky it worked ok for everyone. Now that I’m more experienced and I would do it differently. </a:t>
+            </a:r>
+            <a:r>
+              <a:rPr lang="en-GB" dirty="0"/>
+              <a:t>I should have had an ethic plan and I should have made sure that people involved - like my observers - were trauma informed.</a:t>
             </a:r>
             <a:endParaRPr dirty="0">
               <a:solidFill>
@@ -13742,7 +13680,18 @@
                 <a:cs typeface="Roboto"/>
                 <a:sym typeface="Roboto"/>
               </a:rPr>
-              <a:t>We got a lot of insights with only two rounds of research.</a:t>
+              <a:t>We got a lot of insights with only two rounds of research. </a:t>
+            </a:r>
+            <a:r>
+              <a:rPr lang="en-GB" dirty="0"/>
+              <a:t>For example, we realised that we needed a triage question quite early on, so that homeless people would not go through the form,   instead we gave them a phone number to contact the council where they would get support quickly.</a:t>
+            </a:r>
+            <a:br>
+              <a:rPr lang="en-GB" dirty="0"/>
+            </a:br>
+            <a:r>
+              <a:rPr lang="en-GB" dirty="0"/>
+              <a:t>This simplified the form a lot.</a:t>
             </a:r>
             <a:endParaRPr dirty="0">
               <a:solidFill>
@@ -36684,7 +36633,7 @@
       </p:sp>
       <p:pic>
         <p:nvPicPr>
-          <p:cNvPr id="3" name="Picture 2" descr="busy menu at the top the item Network is framed in red with the number 1 next to it">
+          <p:cNvPr id="3" name="Picture 2" descr="busy menu at the top the item Network is fhighlighted and there is a drop down list with various network speed. Slow 4G is selected.">
             <a:extLst>
               <a:ext uri="{FF2B5EF4-FFF2-40B4-BE49-F238E27FC236}">
                 <a16:creationId xmlns:a16="http://schemas.microsoft.com/office/drawing/2014/main" id="{80ABD9F5-F84D-3EB5-687E-40A2F4F9321F}"/>
@@ -37500,9 +37449,40 @@
               </a:rPr>
               <a:t> - GOV.UK - useful to assess your participants skills</a:t>
             </a:r>
+          </a:p>
+          <a:p>
+            <a:pPr marL="457200" indent="-355600">
+              <a:lnSpc>
+                <a:spcPct val="150000"/>
+              </a:lnSpc>
+              <a:spcBef>
+                <a:spcPts val="1000"/>
+              </a:spcBef>
+              <a:buClr>
+                <a:srgbClr val="FFFFFF"/>
+              </a:buClr>
+              <a:buSzPts val="2000"/>
+              <a:buFont typeface="Roboto"/>
+              <a:buChar char="●"/>
+            </a:pPr>
+            <a:r>
+              <a:rPr lang="en-GB" sz="2000" u="sng" dirty="0">
+                <a:solidFill>
+                  <a:schemeClr val="bg1"/>
+                </a:solidFill>
+                <a:hlinkClick r:id="rId7">
+                  <a:extLst>
+                    <a:ext uri="{A12FA001-AC4F-418D-AE19-62706E023703}">
+                      <ahyp:hlinkClr xmlns:ahyp="http://schemas.microsoft.com/office/drawing/2018/hyperlinkcolor" val="tx"/>
+                    </a:ext>
+                  </a:extLst>
+                </a:hlinkClick>
+              </a:rPr>
+              <a:t>My demo videos to simulations using Chrome dev tools</a:t>
+            </a:r>
             <a:endParaRPr sz="2000" dirty="0">
               <a:solidFill>
-                <a:srgbClr val="FFFFFF"/>
+                <a:schemeClr val="bg1"/>
               </a:solidFill>
               <a:latin typeface="Roboto"/>
               <a:ea typeface="Roboto"/>
@@ -42474,7 +42454,7 @@
             <a:r>
               <a:rPr lang="en-GB" u="sng" dirty="0">
                 <a:solidFill>
-                  <a:schemeClr val="lt1"/>
+                  <a:schemeClr val="bg1"/>
                 </a:solidFill>
                 <a:hlinkClick r:id="rId7">
                   <a:extLst>
@@ -42484,25 +42464,13 @@
                   </a:extLst>
                 </a:hlinkClick>
               </a:rPr>
-              <a:t>Liberating Structures: Change Methods for Everybody Every Day</a:t>
+              <a:t>Liberating Structures – new website</a:t>
             </a:r>
             <a:endParaRPr dirty="0">
               <a:solidFill>
-                <a:schemeClr val="lt1"/>
+                <a:schemeClr val="bg1"/>
               </a:solidFill>
             </a:endParaRPr>
-          </a:p>
-          <a:p>
-            <a:pPr marL="0" lvl="0" indent="0" algn="l" rtl="0">
-              <a:spcBef>
-                <a:spcPts val="1200"/>
-              </a:spcBef>
-              <a:spcAft>
-                <a:spcPts val="0"/>
-              </a:spcAft>
-              <a:buNone/>
-            </a:pPr>
-            <a:endParaRPr dirty="0"/>
           </a:p>
           <a:p>
             <a:pPr marL="0" lvl="0" indent="0" algn="l" rtl="0">
@@ -43367,7 +43335,7 @@
               <a:buChar char="●"/>
             </a:pPr>
             <a:r>
-              <a:rPr lang="en-GB" sz="2000">
+              <a:rPr lang="en-GB" sz="2000" dirty="0">
                 <a:solidFill>
                   <a:srgbClr val="434343"/>
                 </a:solidFill>
@@ -43378,7 +43346,7 @@
               </a:rPr>
               <a:t>Syrian refugees  + interpreters</a:t>
             </a:r>
-            <a:endParaRPr sz="2000">
+            <a:endParaRPr sz="2000" dirty="0">
               <a:solidFill>
                 <a:srgbClr val="434343"/>
               </a:solidFill>
@@ -43407,7 +43375,7 @@
               <a:buChar char="●"/>
             </a:pPr>
             <a:r>
-              <a:rPr lang="en-GB" sz="2000">
+              <a:rPr lang="en-GB" sz="2000" dirty="0">
                 <a:solidFill>
                   <a:srgbClr val="434343"/>
                 </a:solidFill>
@@ -43418,7 +43386,7 @@
               </a:rPr>
               <a:t>low digital skills</a:t>
             </a:r>
-            <a:endParaRPr sz="2000">
+            <a:endParaRPr sz="2000" dirty="0">
               <a:solidFill>
                 <a:srgbClr val="434343"/>
               </a:solidFill>
@@ -43447,7 +43415,7 @@
               <a:buChar char="●"/>
             </a:pPr>
             <a:r>
-              <a:rPr lang="en-GB" sz="2000">
+              <a:rPr lang="en-GB" sz="2000" dirty="0">
                 <a:solidFill>
                   <a:srgbClr val="434343"/>
                 </a:solidFill>
@@ -43458,7 +43426,7 @@
               </a:rPr>
               <a:t>people at risk of homelessness</a:t>
             </a:r>
-            <a:endParaRPr sz="2000">
+            <a:endParaRPr sz="2000" dirty="0">
               <a:solidFill>
                 <a:srgbClr val="434343"/>
               </a:solidFill>
@@ -43487,7 +43455,7 @@
               <a:buChar char="●"/>
             </a:pPr>
             <a:r>
-              <a:rPr lang="en-GB" sz="2000">
+              <a:rPr lang="en-GB" sz="2000" dirty="0">
                 <a:solidFill>
                   <a:srgbClr val="434343"/>
                 </a:solidFill>
@@ -43498,7 +43466,7 @@
               </a:rPr>
               <a:t>one teenager + their support worker</a:t>
             </a:r>
-            <a:endParaRPr sz="2000">
+            <a:endParaRPr sz="2000" dirty="0">
               <a:solidFill>
                 <a:srgbClr val="434343"/>
               </a:solidFill>
@@ -44460,7 +44428,7 @@
               <a:buNone/>
             </a:pPr>
             <a:r>
-              <a:rPr lang="en-GB" sz="2000" b="1">
+              <a:rPr lang="en-GB" sz="2000" b="1" dirty="0">
                 <a:solidFill>
                   <a:srgbClr val="A60070"/>
                 </a:solidFill>
@@ -44469,9 +44437,9 @@
                 <a:cs typeface="Roboto"/>
                 <a:sym typeface="Roboto"/>
               </a:rPr>
-              <a:t>1 in 4 person is disabled</a:t>
-            </a:r>
-            <a:endParaRPr b="1">
+              <a:t>1 in 4 person are disabled</a:t>
+            </a:r>
+            <a:endParaRPr b="1" dirty="0">
               <a:solidFill>
                 <a:srgbClr val="A60070"/>
               </a:solidFill>
@@ -44525,7 +44493,7 @@
               <a:buNone/>
             </a:pPr>
             <a:r>
-              <a:rPr lang="en-GB" sz="2000" b="1">
+              <a:rPr lang="en-GB" sz="2000" b="1" dirty="0">
                 <a:solidFill>
                   <a:srgbClr val="1D5C65"/>
                 </a:solidFill>
@@ -44534,9 +44502,9 @@
                 <a:cs typeface="Roboto"/>
                 <a:sym typeface="Roboto"/>
               </a:rPr>
-              <a:t>1 in 7 person is neurodivergent</a:t>
-            </a:r>
-            <a:endParaRPr b="1">
+              <a:t>1 in 7 person are neurodivergent</a:t>
+            </a:r>
+            <a:endParaRPr b="1" dirty="0">
               <a:solidFill>
                 <a:srgbClr val="1D5C65"/>
               </a:solidFill>

</xml_diff>